<commit_message>
docs: resync figure numbering from Drive decks (2026-10-29)
Changed decks: Fig R3 (new slide 7). Fig MyM, Fig R1, Fig R2: export noise only.

No slug number changes. Fig R3 slide 7 now contains remap_tf_noise_gsea
(already numbered R3.7): estado revisar -> listo. chipatlas_histonas is
still absent from the deck (7 slides): stays revisar, note updated.

Co-Authored-By: Claude Opus 5.5 <noreply@anthropic.com>
</commit_message>
<xml_diff>
--- a/docs/Fig R3.pptx
+++ b/docs/Fig R3.pptx
@@ -2,18 +2,19 @@
 <file path=ppt/presentation.xml><?xml version="1.0" encoding="utf-8"?>
 <p:presentation xmlns:a="http://schemas.openxmlformats.org/drawingml/2006/main" xmlns:r="http://schemas.openxmlformats.org/officeDocument/2006/relationships" xmlns:mc="http://schemas.openxmlformats.org/markup-compatibility/2006" xmlns:mv="urn:schemas-microsoft-com:mac:vml" xmlns:p="http://schemas.openxmlformats.org/presentationml/2006/main" xmlns:c="http://schemas.openxmlformats.org/drawingml/2006/chart" xmlns:dgm="http://schemas.openxmlformats.org/drawingml/2006/diagram" xmlns:o="urn:schemas-microsoft-com:office:office" xmlns:v="urn:schemas-microsoft-com:vml" xmlns:pvml="urn:schemas-microsoft-com:office:powerpoint" xmlns:com="http://schemas.openxmlformats.org/drawingml/2006/compatibility" xmlns:p14="http://schemas.microsoft.com/office/powerpoint/2010/main" xmlns:p15="http://schemas.microsoft.com/office/powerpoint/2012/main" xmlns:ahyp="http://schemas.microsoft.com/office/drawing/2018/hyperlinkcolor" autoCompressPictures="0" strictFirstAndLastChars="0" saveSubsetFonts="1">
   <p:sldMasterIdLst>
-    <p:sldMasterId id="2147483659" r:id="rId5"/>
+    <p:sldMasterId id="2147483659" r:id="rId4"/>
   </p:sldMasterIdLst>
   <p:notesMasterIdLst>
-    <p:notesMasterId r:id="rId6"/>
+    <p:notesMasterId r:id="rId5"/>
   </p:notesMasterIdLst>
   <p:sldIdLst>
-    <p:sldId id="256" r:id="rId7"/>
-    <p:sldId id="257" r:id="rId8"/>
-    <p:sldId id="258" r:id="rId9"/>
-    <p:sldId id="259" r:id="rId10"/>
-    <p:sldId id="260" r:id="rId11"/>
-    <p:sldId id="261" r:id="rId12"/>
+    <p:sldId id="256" r:id="rId6"/>
+    <p:sldId id="257" r:id="rId7"/>
+    <p:sldId id="258" r:id="rId8"/>
+    <p:sldId id="259" r:id="rId9"/>
+    <p:sldId id="260" r:id="rId10"/>
+    <p:sldId id="261" r:id="rId11"/>
+    <p:sldId id="262" r:id="rId12"/>
   </p:sldIdLst>
   <p:sldSz cy="5143500" cx="9144000"/>
   <p:notesSz cx="6858000" cy="9144000"/>
@@ -263,21 +264,6 @@
     </p:ext>
   </p:extLst>
 </p:presentation>
-</file>
-
-<file path=ppt/commentAuthors.xml><?xml version="1.0" encoding="utf-8"?>
-<p:cmAuthorLst xmlns:a="http://schemas.openxmlformats.org/drawingml/2006/main" xmlns:r="http://schemas.openxmlformats.org/officeDocument/2006/relationships" xmlns:mc="http://schemas.openxmlformats.org/markup-compatibility/2006" xmlns:mv="urn:schemas-microsoft-com:mac:vml" xmlns:p="http://schemas.openxmlformats.org/presentationml/2006/main" xmlns:c="http://schemas.openxmlformats.org/drawingml/2006/chart" xmlns:dgm="http://schemas.openxmlformats.org/drawingml/2006/diagram" xmlns:o="urn:schemas-microsoft-com:office:office" xmlns:v="urn:schemas-microsoft-com:vml" xmlns:pvml="urn:schemas-microsoft-com:office:powerpoint" xmlns:com="http://schemas.openxmlformats.org/drawingml/2006/compatibility" xmlns:p14="http://schemas.microsoft.com/office/powerpoint/2010/main" xmlns:p15="http://schemas.microsoft.com/office/powerpoint/2012/main" xmlns:ahyp="http://schemas.microsoft.com/office/drawing/2018/hyperlinkcolor">
-  <p:cmAuthor clrIdx="0" id="0" initials="" lastIdx="1" name="Martin Iungman"/>
-</p:cmAuthorLst>
-</file>
-
-<file path=ppt/comments/comment1.xml><?xml version="1.0" encoding="utf-8"?>
-<p:cmLst xmlns:a="http://schemas.openxmlformats.org/drawingml/2006/main" xmlns:r="http://schemas.openxmlformats.org/officeDocument/2006/relationships" xmlns:mc="http://schemas.openxmlformats.org/markup-compatibility/2006" xmlns:mv="urn:schemas-microsoft-com:mac:vml" xmlns:p="http://schemas.openxmlformats.org/presentationml/2006/main" xmlns:c="http://schemas.openxmlformats.org/drawingml/2006/chart" xmlns:dgm="http://schemas.openxmlformats.org/drawingml/2006/diagram" xmlns:o="urn:schemas-microsoft-com:office:office" xmlns:v="urn:schemas-microsoft-com:vml" xmlns:pvml="urn:schemas-microsoft-com:office:powerpoint" xmlns:com="http://schemas.openxmlformats.org/drawingml/2006/compatibility" xmlns:p14="http://schemas.microsoft.com/office/powerpoint/2010/main" xmlns:p15="http://schemas.microsoft.com/office/powerpoint/2012/main" xmlns:ahyp="http://schemas.microsoft.com/office/drawing/2018/hyperlinkcolor">
-  <p:cm authorId="0" idx="1" dt="2026-10-20T16:38:31.281">
-    <p:pos x="4160" y="96"/>
-    <p:text>revisar y acortar la leyenda</p:text>
-  </p:cm>
-</p:cmLst>
 </file>
 
 <file path=ppt/notesMasters/notesMaster1.xml><?xml version="1.0" encoding="utf-8"?>
@@ -810,7 +796,7 @@
   <p:cSld>
     <p:spTree>
       <p:nvGrpSpPr>
-        <p:cNvPr id="56" name="Shape 56"/>
+        <p:cNvPr id="55" name="Shape 55"/>
         <p:cNvGrpSpPr/>
         <p:nvPr/>
       </p:nvGrpSpPr>
@@ -824,7 +810,7 @@
       </p:grpSpPr>
       <p:sp>
         <p:nvSpPr>
-          <p:cNvPr id="57" name="Google Shape;57;p:notes"/>
+          <p:cNvPr id="56" name="Google Shape;56;p:notes"/>
           <p:cNvSpPr/>
           <p:nvPr>
             <p:ph idx="2" type="sldImg"/>
@@ -859,7 +845,7 @@
       </p:sp>
       <p:sp>
         <p:nvSpPr>
-          <p:cNvPr id="58" name="Google Shape;58;p:notes"/>
+          <p:cNvPr id="57" name="Google Shape;57;p:notes"/>
           <p:cNvSpPr txBox="1"/>
           <p:nvPr>
             <p:ph idx="1" type="body"/>
@@ -909,7 +895,7 @@
   <p:cSld>
     <p:spTree>
       <p:nvGrpSpPr>
-        <p:cNvPr id="61" name="Shape 61"/>
+        <p:cNvPr id="60" name="Shape 60"/>
         <p:cNvGrpSpPr/>
         <p:nvPr/>
       </p:nvGrpSpPr>
@@ -923,7 +909,7 @@
       </p:grpSpPr>
       <p:sp>
         <p:nvSpPr>
-          <p:cNvPr id="62" name="Google Shape;62;h701cfb41a30eeeb4_0_17:notes"/>
+          <p:cNvPr id="61" name="Google Shape;61;h701cfb41a30eeeb4_0_17:notes"/>
           <p:cNvSpPr/>
           <p:nvPr>
             <p:ph idx="2" type="sldImg"/>
@@ -958,7 +944,7 @@
       </p:sp>
       <p:sp>
         <p:nvSpPr>
-          <p:cNvPr id="63" name="Google Shape;63;h701cfb41a30eeeb4_0_17:notes"/>
+          <p:cNvPr id="62" name="Google Shape;62;h701cfb41a30eeeb4_0_17:notes"/>
           <p:cNvSpPr txBox="1"/>
           <p:nvPr>
             <p:ph idx="1" type="body"/>
@@ -1008,7 +994,7 @@
   <p:cSld>
     <p:spTree>
       <p:nvGrpSpPr>
-        <p:cNvPr id="67" name="Shape 67"/>
+        <p:cNvPr id="65" name="Shape 65"/>
         <p:cNvGrpSpPr/>
         <p:nvPr/>
       </p:nvGrpSpPr>
@@ -1022,7 +1008,7 @@
       </p:grpSpPr>
       <p:sp>
         <p:nvSpPr>
-          <p:cNvPr id="68" name="Google Shape;68;h701cfb41a30eeeb4_0_9:notes"/>
+          <p:cNvPr id="66" name="Google Shape;66;h701cfb41a30eeeb4_0_9:notes"/>
           <p:cNvSpPr/>
           <p:nvPr>
             <p:ph idx="2" type="sldImg"/>
@@ -1057,7 +1043,7 @@
       </p:sp>
       <p:sp>
         <p:nvSpPr>
-          <p:cNvPr id="69" name="Google Shape;69;h701cfb41a30eeeb4_0_9:notes"/>
+          <p:cNvPr id="67" name="Google Shape;67;h701cfb41a30eeeb4_0_9:notes"/>
           <p:cNvSpPr txBox="1"/>
           <p:nvPr>
             <p:ph idx="1" type="body"/>
@@ -1107,7 +1093,7 @@
   <p:cSld>
     <p:spTree>
       <p:nvGrpSpPr>
-        <p:cNvPr id="72" name="Shape 72"/>
+        <p:cNvPr id="70" name="Shape 70"/>
         <p:cNvGrpSpPr/>
         <p:nvPr/>
       </p:nvGrpSpPr>
@@ -1121,7 +1107,7 @@
       </p:grpSpPr>
       <p:sp>
         <p:nvSpPr>
-          <p:cNvPr id="73" name="Google Shape;73;g3f5e06a3c09_0_10:notes"/>
+          <p:cNvPr id="71" name="Google Shape;71;h208cec68a3b92c66_0_2:notes"/>
           <p:cNvSpPr/>
           <p:nvPr>
             <p:ph idx="2" type="sldImg"/>
@@ -1156,7 +1142,7 @@
       </p:sp>
       <p:sp>
         <p:nvSpPr>
-          <p:cNvPr id="74" name="Google Shape;74;g3f5e06a3c09_0_10:notes"/>
+          <p:cNvPr id="72" name="Google Shape;72;h208cec68a3b92c66_0_2:notes"/>
           <p:cNvSpPr txBox="1"/>
           <p:nvPr>
             <p:ph idx="1" type="body"/>
@@ -1206,7 +1192,7 @@
   <p:cSld>
     <p:spTree>
       <p:nvGrpSpPr>
-        <p:cNvPr id="77" name="Shape 77"/>
+        <p:cNvPr id="75" name="Shape 75"/>
         <p:cNvGrpSpPr/>
         <p:nvPr/>
       </p:nvGrpSpPr>
@@ -1220,7 +1206,7 @@
       </p:grpSpPr>
       <p:sp>
         <p:nvSpPr>
-          <p:cNvPr id="78" name="Google Shape;78;g3f5e06a3c09_0_16:notes"/>
+          <p:cNvPr id="76" name="Google Shape;76;g3f5e06a3c09_0_10:notes"/>
           <p:cNvSpPr/>
           <p:nvPr>
             <p:ph idx="2" type="sldImg"/>
@@ -1255,7 +1241,106 @@
       </p:sp>
       <p:sp>
         <p:nvSpPr>
-          <p:cNvPr id="79" name="Google Shape;79;g3f5e06a3c09_0_16:notes"/>
+          <p:cNvPr id="77" name="Google Shape;77;g3f5e06a3c09_0_10:notes"/>
+          <p:cNvSpPr txBox="1"/>
+          <p:nvPr>
+            <p:ph idx="1" type="body"/>
+          </p:nvPr>
+        </p:nvSpPr>
+        <p:spPr>
+          <a:xfrm>
+            <a:off x="685800" y="4343400"/>
+            <a:ext cx="5486400" cy="4114800"/>
+          </a:xfrm>
+          <a:prstGeom prst="rect">
+            <a:avLst/>
+          </a:prstGeom>
+        </p:spPr>
+        <p:txBody>
+          <a:bodyPr anchorCtr="0" anchor="t" bIns="91425" lIns="91425" spcFirstLastPara="1" rIns="91425" wrap="square" tIns="91425">
+            <a:noAutofit/>
+          </a:bodyPr>
+          <a:lstStyle/>
+          <a:p>
+            <a:pPr indent="0" lvl="0" marL="0" rtl="0" algn="l">
+              <a:spcBef>
+                <a:spcPts val="0"/>
+              </a:spcBef>
+              <a:spcAft>
+                <a:spcPts val="0"/>
+              </a:spcAft>
+              <a:buNone/>
+            </a:pPr>
+            <a:r>
+              <a:t/>
+            </a:r>
+            <a:endParaRPr/>
+          </a:p>
+        </p:txBody>
+      </p:sp>
+    </p:spTree>
+  </p:cSld>
+  <p:clrMapOvr>
+    <a:masterClrMapping/>
+  </p:clrMapOvr>
+</p:notes>
+</file>
+
+<file path=ppt/notesSlides/notesSlide7.xml><?xml version="1.0" encoding="utf-8"?>
+<p:notes xmlns:a="http://schemas.openxmlformats.org/drawingml/2006/main" xmlns:r="http://schemas.openxmlformats.org/officeDocument/2006/relationships" xmlns:mc="http://schemas.openxmlformats.org/markup-compatibility/2006" xmlns:mv="urn:schemas-microsoft-com:mac:vml" xmlns:p="http://schemas.openxmlformats.org/presentationml/2006/main" xmlns:c="http://schemas.openxmlformats.org/drawingml/2006/chart" xmlns:dgm="http://schemas.openxmlformats.org/drawingml/2006/diagram" xmlns:o="urn:schemas-microsoft-com:office:office" xmlns:v="urn:schemas-microsoft-com:vml" xmlns:pvml="urn:schemas-microsoft-com:office:powerpoint" xmlns:com="http://schemas.openxmlformats.org/drawingml/2006/compatibility" xmlns:p14="http://schemas.microsoft.com/office/powerpoint/2010/main" xmlns:p15="http://schemas.microsoft.com/office/powerpoint/2012/main" xmlns:ahyp="http://schemas.microsoft.com/office/drawing/2018/hyperlinkcolor" showMasterPhAnim="0" showMasterSp="0">
+  <p:cSld>
+    <p:spTree>
+      <p:nvGrpSpPr>
+        <p:cNvPr id="80" name="Shape 80"/>
+        <p:cNvGrpSpPr/>
+        <p:nvPr/>
+      </p:nvGrpSpPr>
+      <p:grpSpPr>
+        <a:xfrm>
+          <a:off x="0" y="0"/>
+          <a:ext cx="0" cy="0"/>
+          <a:chOff x="0" y="0"/>
+          <a:chExt cx="0" cy="0"/>
+        </a:xfrm>
+      </p:grpSpPr>
+      <p:sp>
+        <p:nvSpPr>
+          <p:cNvPr id="81" name="Google Shape;81;g3f5e06a3c09_0_16:notes"/>
+          <p:cNvSpPr/>
+          <p:nvPr>
+            <p:ph idx="2" type="sldImg"/>
+          </p:nvPr>
+        </p:nvSpPr>
+        <p:spPr>
+          <a:xfrm>
+            <a:off x="381300" y="685800"/>
+            <a:ext cx="6096000" cy="3429000"/>
+          </a:xfrm>
+          <a:custGeom>
+            <a:rect b="b" l="l" r="r" t="t"/>
+            <a:pathLst>
+              <a:path extrusionOk="0" h="120000" w="120000">
+                <a:moveTo>
+                  <a:pt x="0" y="0"/>
+                </a:moveTo>
+                <a:lnTo>
+                  <a:pt x="120000" y="0"/>
+                </a:lnTo>
+                <a:lnTo>
+                  <a:pt x="120000" y="120000"/>
+                </a:lnTo>
+                <a:lnTo>
+                  <a:pt x="0" y="120000"/>
+                </a:lnTo>
+                <a:close/>
+              </a:path>
+            </a:pathLst>
+          </a:custGeom>
+        </p:spPr>
+      </p:sp>
+      <p:sp>
+        <p:nvSpPr>
+          <p:cNvPr id="82" name="Google Shape;82;g3f5e06a3c09_0_16:notes"/>
           <p:cNvSpPr txBox="1"/>
           <p:nvPr>
             <p:ph idx="1" type="body"/>
@@ -5973,7 +6058,7 @@
           <p:nvPr/>
         </p:nvPicPr>
         <p:blipFill>
-          <a:blip r:embed="rId4">
+          <a:blip r:embed="rId3">
             <a:alphaModFix/>
           </a:blip>
           <a:stretch>
@@ -5994,83 +6079,6 @@
           </a:ln>
         </p:spPr>
       </p:pic>
-      <p:sp>
-        <p:nvSpPr>
-          <p:cNvPr id="55" name="Google Shape;55;p13"/>
-          <p:cNvSpPr txBox="1"/>
-          <p:nvPr/>
-        </p:nvSpPr>
-        <p:spPr>
-          <a:xfrm>
-            <a:off x="6604000" y="152400"/>
-            <a:ext cx="3000000" cy="3989700"/>
-          </a:xfrm>
-          <a:prstGeom prst="rect">
-            <a:avLst/>
-          </a:prstGeom>
-          <a:noFill/>
-          <a:ln>
-            <a:noFill/>
-          </a:ln>
-        </p:spPr>
-        <p:txBody>
-          <a:bodyPr anchorCtr="0" anchor="t" bIns="91425" lIns="91425" spcFirstLastPara="1" rIns="91425" wrap="square" tIns="91425">
-            <a:spAutoFit/>
-          </a:bodyPr>
-          <a:lstStyle/>
-          <a:p>
-            <a:pPr indent="0" lvl="0" marL="0" rtl="0" algn="l">
-              <a:lnSpc>
-                <a:spcPct val="115000"/>
-              </a:lnSpc>
-              <a:spcBef>
-                <a:spcPts val="1200"/>
-              </a:spcBef>
-              <a:spcAft>
-                <a:spcPts val="1200"/>
-              </a:spcAft>
-              <a:buNone/>
-            </a:pPr>
-            <a:r>
-              <a:rPr b="1" lang="es-419" sz="800">
-                <a:solidFill>
-                  <a:schemeClr val="dk1"/>
-                </a:solidFill>
-              </a:rPr>
-              <a:t>Fig. R3.1. Medición del ruido transcripcional desacoplado de la actividad.</a:t>
-            </a:r>
-            <a:r>
-              <a:rPr lang="es-419" sz="800">
-                <a:solidFill>
-                  <a:schemeClr val="dk1"/>
-                </a:solidFill>
-              </a:rPr>
-              <a:t> (A) Construcción de la métrica de ruido en la réplica 1. A la izquierda, varianza en función de la actividad media de cada promotor; las bandas alternadas delimitan los intervalos de 100 promotores de actividad similar, y en rojo se resalta un intervalo de actividad intermedia (intervalo 56). En el centro, los 100 promotores de ese intervalo ordenados por su varianza, con el rango de 1 a 100 asignado a cada uno. A la derecha, distribución de las lecturas normalizadas entre las fracciones de </a:t>
-            </a:r>
-            <a:r>
-              <a:rPr i="1" lang="es-419" sz="800">
-                <a:solidFill>
-                  <a:schemeClr val="dk1"/>
-                </a:solidFill>
-              </a:rPr>
-              <a:t>sorting</a:t>
-            </a:r>
-            <a:r>
-              <a:rPr lang="es-419" sz="800">
-                <a:solidFill>
-                  <a:schemeClr val="dk1"/>
-                </a:solidFill>
-              </a:rPr>
-              <a:t> para dos promotores de ese intervalo: MYLPF_1 (rango 10, en ámbar) y CDK11B_1 (rango 90, en violeta); la línea punteada indica la actividad media de ambos. (B) Rango de varianza dentro de cada intervalo en función del intervalo de actividad media para todos los promotores de la réplica 1, con el intervalo y los promotores de A resaltados. La línea indica la tendencia (LOESS), que por construcción es constante en 50 (línea punteada). (C) Reproducibilidad del rango de varianza entre réplicas. Para los 10.381 promotores medidos en ambas réplicas, se muestra el rango medio en la réplica 2 (con su IC 95%) para cada decil del rango en la réplica 1, para el conjunto de los promotores (negro) y por separado según el tercil de actividad (promedio del percentil de actividad en ambas réplicas; tonos de azul). La línea punteada indica el valor esperado en ausencia de reproducibilidad. Las bandas sombreadas indican los deciles en los que se ubican los promotores de ejemplo, con su rango en cada réplica.</a:t>
-            </a:r>
-            <a:endParaRPr sz="800">
-              <a:solidFill>
-                <a:schemeClr val="dk1"/>
-              </a:solidFill>
-            </a:endParaRPr>
-          </a:p>
-        </p:txBody>
-      </p:sp>
     </p:spTree>
   </p:cSld>
   <p:clrMapOvr>
@@ -6084,7 +6092,7 @@
   <p:cSld>
     <p:spTree>
       <p:nvGrpSpPr>
-        <p:cNvPr id="59" name="Shape 59"/>
+        <p:cNvPr id="58" name="Shape 58"/>
         <p:cNvGrpSpPr/>
         <p:nvPr/>
       </p:nvGrpSpPr>
@@ -6098,7 +6106,7 @@
       </p:grpSpPr>
       <p:pic>
         <p:nvPicPr>
-          <p:cNvPr id="60" name="Google Shape;60;p14" title="ruido_cgi.jpg"/>
+          <p:cNvPr id="59" name="Google Shape;59;p14" title="ruido_cgi.jpg"/>
           <p:cNvPicPr preferRelativeResize="0"/>
           <p:nvPr/>
         </p:nvPicPr>
@@ -6112,8 +6120,8 @@
         </p:blipFill>
         <p:spPr>
           <a:xfrm>
-            <a:off x="1113925" y="1009271"/>
-            <a:ext cx="6076948" cy="2563726"/>
+            <a:off x="152400" y="152400"/>
+            <a:ext cx="8839204" cy="3729039"/>
           </a:xfrm>
           <a:prstGeom prst="rect">
             <a:avLst/>
@@ -6137,7 +6145,7 @@
   <p:cSld>
     <p:spTree>
       <p:nvGrpSpPr>
-        <p:cNvPr id="64" name="Shape 64"/>
+        <p:cNvPr id="63" name="Shape 63"/>
         <p:cNvGrpSpPr/>
         <p:nvPr/>
       </p:nvGrpSpPr>
@@ -6149,63 +6157,9 @@
           <a:chExt cx="0" cy="0"/>
         </a:xfrm>
       </p:grpSpPr>
-      <p:sp>
-        <p:nvSpPr>
-          <p:cNvPr id="65" name="Google Shape;65;p15"/>
-          <p:cNvSpPr txBox="1"/>
-          <p:nvPr/>
-        </p:nvSpPr>
-        <p:spPr>
-          <a:xfrm>
-            <a:off x="4797925" y="916175"/>
-            <a:ext cx="3000000" cy="3232500"/>
-          </a:xfrm>
-          <a:prstGeom prst="rect">
-            <a:avLst/>
-          </a:prstGeom>
-          <a:noFill/>
-          <a:ln>
-            <a:noFill/>
-          </a:ln>
-        </p:spPr>
-        <p:txBody>
-          <a:bodyPr anchorCtr="0" anchor="t" bIns="91425" lIns="91425" spcFirstLastPara="1" rIns="91425" wrap="square" tIns="91425">
-            <a:spAutoFit/>
-          </a:bodyPr>
-          <a:lstStyle/>
-          <a:p>
-            <a:pPr indent="0" lvl="0" marL="0" rtl="0" algn="l">
-              <a:spcBef>
-                <a:spcPts val="0"/>
-              </a:spcBef>
-              <a:spcAft>
-                <a:spcPts val="0"/>
-              </a:spcAft>
-              <a:buNone/>
-            </a:pPr>
-            <a:r>
-              <a:rPr b="1" lang="es-419" sz="1100">
-                <a:solidFill>
-                  <a:schemeClr val="dk1"/>
-                </a:solidFill>
-              </a:rPr>
-              <a:t>Fig. R3.3. El ruido se asocia con la composición del fragmento de manera distinta que la actividad.</a:t>
-            </a:r>
-            <a:r>
-              <a:rPr lang="es-419" sz="1100">
-                <a:solidFill>
-                  <a:schemeClr val="dk1"/>
-                </a:solidFill>
-              </a:rPr>
-              <a:t> (A) Rango de varianza medio de los promotores en cada decil de la razón CpG observado/esperado del fragmento, para las réplicas 1 y 2. Cada punto se ubica en la mediana del decil, y las barras verticales indican el IC 95%. La línea punteada vertical indica el valor de 0,6 que define a las islas CpG, y la línea punteada horizontal, el rango medio esperado en ausencia de asociación. Se indica el ρ de Spearman entre la razón CpG o/e y el rango de varianza de cada réplica. (B) Igual que en A, para el contenido de G+C del fragmento; la línea punteada vertical indica el 50%, el valor de contenido de G+C de la definición de isla. </a:t>
-            </a:r>
-            <a:endParaRPr/>
-          </a:p>
-        </p:txBody>
-      </p:sp>
       <p:pic>
         <p:nvPicPr>
-          <p:cNvPr id="66" name="Google Shape;66;p15" title="ruido_composicion_deciles.jpg"/>
+          <p:cNvPr id="64" name="Google Shape;64;p15" title="ruido_composicion_deciles.jpg"/>
           <p:cNvPicPr preferRelativeResize="0"/>
           <p:nvPr/>
         </p:nvPicPr>
@@ -6244,7 +6198,7 @@
   <p:cSld>
     <p:spTree>
       <p:nvGrpSpPr>
-        <p:cNvPr id="70" name="Shape 70"/>
+        <p:cNvPr id="68" name="Shape 68"/>
         <p:cNvGrpSpPr/>
         <p:nvPr/>
       </p:nvGrpSpPr>
@@ -6258,7 +6212,7 @@
       </p:grpSpPr>
       <p:pic>
         <p:nvPicPr>
-          <p:cNvPr id="71" name="Google Shape;71;p16" title="ruido_tata.jpg"/>
+          <p:cNvPr id="69" name="Google Shape;69;p16" title="ruido_tata.jpg"/>
           <p:cNvPicPr preferRelativeResize="0"/>
           <p:nvPr/>
         </p:nvPicPr>
@@ -6297,7 +6251,7 @@
   <p:cSld>
     <p:spTree>
       <p:nvGrpSpPr>
-        <p:cNvPr id="75" name="Shape 75"/>
+        <p:cNvPr id="73" name="Shape 73"/>
         <p:cNvGrpSpPr/>
         <p:nvPr/>
       </p:nvGrpSpPr>
@@ -6311,7 +6265,7 @@
       </p:grpSpPr>
       <p:pic>
         <p:nvPicPr>
-          <p:cNvPr id="76" name="Google Shape;76;p17" title="summary_noise.jpg"/>
+          <p:cNvPr id="74" name="Google Shape;74;p17" title="tata_ruido_especificidad.jpg"/>
           <p:cNvPicPr preferRelativeResize="0"/>
           <p:nvPr/>
         </p:nvPicPr>
@@ -6326,7 +6280,7 @@
         <p:spPr>
           <a:xfrm>
             <a:off x="152400" y="152400"/>
-            <a:ext cx="8839204" cy="4419602"/>
+            <a:ext cx="6910500" cy="4838700"/>
           </a:xfrm>
           <a:prstGeom prst="rect">
             <a:avLst/>
@@ -6350,7 +6304,7 @@
   <p:cSld>
     <p:spTree>
       <p:nvGrpSpPr>
-        <p:cNvPr id="80" name="Shape 80"/>
+        <p:cNvPr id="78" name="Shape 78"/>
         <p:cNvGrpSpPr/>
         <p:nvPr/>
       </p:nvGrpSpPr>
@@ -6362,84 +6316,87 @@
           <a:chExt cx="0" cy="0"/>
         </a:xfrm>
       </p:grpSpPr>
-      <p:sp>
-        <p:nvSpPr>
-          <p:cNvPr id="81" name="Google Shape;81;p18"/>
-          <p:cNvSpPr txBox="1"/>
-          <p:nvPr>
-            <p:ph type="title"/>
-          </p:nvPr>
-        </p:nvSpPr>
+      <p:pic>
+        <p:nvPicPr>
+          <p:cNvPr id="79" name="Google Shape;79;p18" title="summary_noise.jpg"/>
+          <p:cNvPicPr preferRelativeResize="0"/>
+          <p:nvPr/>
+        </p:nvPicPr>
+        <p:blipFill>
+          <a:blip r:embed="rId3">
+            <a:alphaModFix/>
+          </a:blip>
+          <a:stretch>
+            <a:fillRect/>
+          </a:stretch>
+        </p:blipFill>
         <p:spPr>
           <a:xfrm>
-            <a:off x="311700" y="445025"/>
-            <a:ext cx="8520600" cy="572700"/>
+            <a:off x="152400" y="152400"/>
+            <a:ext cx="5705042" cy="4838700"/>
           </a:xfrm>
           <a:prstGeom prst="rect">
             <a:avLst/>
           </a:prstGeom>
+          <a:noFill/>
+          <a:ln>
+            <a:noFill/>
+          </a:ln>
         </p:spPr>
-        <p:txBody>
-          <a:bodyPr anchorCtr="0" anchor="t" bIns="91425" lIns="91425" spcFirstLastPara="1" rIns="91425" wrap="square" tIns="91425">
-            <a:normAutofit fontScale="90000"/>
-          </a:bodyPr>
-          <a:lstStyle/>
-          <a:p>
-            <a:pPr indent="0" lvl="0" marL="0" rtl="0" algn="l">
-              <a:spcBef>
-                <a:spcPts val="0"/>
-              </a:spcBef>
-              <a:spcAft>
-                <a:spcPts val="0"/>
-              </a:spcAft>
-              <a:buNone/>
-            </a:pPr>
-            <a:r>
-              <a:t/>
-            </a:r>
-            <a:endParaRPr/>
-          </a:p>
-        </p:txBody>
-      </p:sp>
-      <p:sp>
-        <p:nvSpPr>
-          <p:cNvPr id="82" name="Google Shape;82;p18"/>
-          <p:cNvSpPr txBox="1"/>
-          <p:nvPr>
-            <p:ph idx="1" type="body"/>
-          </p:nvPr>
-        </p:nvSpPr>
+      </p:pic>
+    </p:spTree>
+  </p:cSld>
+  <p:clrMapOvr>
+    <a:masterClrMapping/>
+  </p:clrMapOvr>
+</p:sld>
+</file>
+
+<file path=ppt/slides/slide7.xml><?xml version="1.0" encoding="utf-8"?>
+<p:sld xmlns:a="http://schemas.openxmlformats.org/drawingml/2006/main" xmlns:r="http://schemas.openxmlformats.org/officeDocument/2006/relationships" xmlns:mc="http://schemas.openxmlformats.org/markup-compatibility/2006" xmlns:mv="urn:schemas-microsoft-com:mac:vml" xmlns:p="http://schemas.openxmlformats.org/presentationml/2006/main" xmlns:c="http://schemas.openxmlformats.org/drawingml/2006/chart" xmlns:dgm="http://schemas.openxmlformats.org/drawingml/2006/diagram" xmlns:o="urn:schemas-microsoft-com:office:office" xmlns:v="urn:schemas-microsoft-com:vml" xmlns:pvml="urn:schemas-microsoft-com:office:powerpoint" xmlns:com="http://schemas.openxmlformats.org/drawingml/2006/compatibility" xmlns:p14="http://schemas.microsoft.com/office/powerpoint/2010/main" xmlns:p15="http://schemas.microsoft.com/office/powerpoint/2012/main" xmlns:ahyp="http://schemas.microsoft.com/office/drawing/2018/hyperlinkcolor">
+  <p:cSld>
+    <p:spTree>
+      <p:nvGrpSpPr>
+        <p:cNvPr id="83" name="Shape 83"/>
+        <p:cNvGrpSpPr/>
+        <p:nvPr/>
+      </p:nvGrpSpPr>
+      <p:grpSpPr>
+        <a:xfrm>
+          <a:off x="0" y="0"/>
+          <a:ext cx="0" cy="0"/>
+          <a:chOff x="0" y="0"/>
+          <a:chExt cx="0" cy="0"/>
+        </a:xfrm>
+      </p:grpSpPr>
+      <p:pic>
+        <p:nvPicPr>
+          <p:cNvPr id="84" name="Google Shape;84;p19" title="remap_tf_noise_gsea.jpg"/>
+          <p:cNvPicPr preferRelativeResize="0"/>
+          <p:nvPr/>
+        </p:nvPicPr>
+        <p:blipFill>
+          <a:blip r:embed="rId3">
+            <a:alphaModFix/>
+          </a:blip>
+          <a:stretch>
+            <a:fillRect/>
+          </a:stretch>
+        </p:blipFill>
         <p:spPr>
           <a:xfrm>
-            <a:off x="311700" y="1152475"/>
-            <a:ext cx="8520600" cy="3416400"/>
+            <a:off x="152400" y="152400"/>
+            <a:ext cx="3936171" cy="4838702"/>
           </a:xfrm>
           <a:prstGeom prst="rect">
             <a:avLst/>
           </a:prstGeom>
+          <a:noFill/>
+          <a:ln>
+            <a:noFill/>
+          </a:ln>
         </p:spPr>
-        <p:txBody>
-          <a:bodyPr anchorCtr="0" anchor="t" bIns="91425" lIns="91425" spcFirstLastPara="1" rIns="91425" wrap="square" tIns="91425">
-            <a:normAutofit/>
-          </a:bodyPr>
-          <a:lstStyle/>
-          <a:p>
-            <a:pPr indent="0" lvl="0" marL="0" rtl="0" algn="l">
-              <a:spcBef>
-                <a:spcPts val="0"/>
-              </a:spcBef>
-              <a:spcAft>
-                <a:spcPts val="1200"/>
-              </a:spcAft>
-              <a:buNone/>
-            </a:pPr>
-            <a:r>
-              <a:t/>
-            </a:r>
-            <a:endParaRPr/>
-          </a:p>
-        </p:txBody>
-      </p:sp>
+      </p:pic>
     </p:spTree>
   </p:cSld>
   <p:clrMapOvr>

</xml_diff>

<commit_message>
docs: resync figure numbering from Drive decks (2026-10-30)
Changed decks: Fig R3 (Fig MyM, R1, R2: export noise only).
No slug number changes.
tata_ruido_especificidad -> revisar: slide now includes an extra image from exploratorio_tata_ruido (p4_distribucion_puntaje).

Co-Authored-By: Claude Opus 5.5 <noreply@anthropic.com>
</commit_message>
<xml_diff>
--- a/docs/Fig R3.pptx
+++ b/docs/Fig R3.pptx
@@ -1192,7 +1192,7 @@
   <p:cSld>
     <p:spTree>
       <p:nvGrpSpPr>
-        <p:cNvPr id="75" name="Shape 75"/>
+        <p:cNvPr id="76" name="Shape 76"/>
         <p:cNvGrpSpPr/>
         <p:nvPr/>
       </p:nvGrpSpPr>
@@ -1206,7 +1206,7 @@
       </p:grpSpPr>
       <p:sp>
         <p:nvSpPr>
-          <p:cNvPr id="76" name="Google Shape;76;g3f5e06a3c09_0_10:notes"/>
+          <p:cNvPr id="77" name="Google Shape;77;g3f5e06a3c09_0_10:notes"/>
           <p:cNvSpPr/>
           <p:nvPr>
             <p:ph idx="2" type="sldImg"/>
@@ -1241,7 +1241,7 @@
       </p:sp>
       <p:sp>
         <p:nvSpPr>
-          <p:cNvPr id="77" name="Google Shape;77;g3f5e06a3c09_0_10:notes"/>
+          <p:cNvPr id="78" name="Google Shape;78;g3f5e06a3c09_0_10:notes"/>
           <p:cNvSpPr txBox="1"/>
           <p:nvPr>
             <p:ph idx="1" type="body"/>
@@ -1291,7 +1291,7 @@
   <p:cSld>
     <p:spTree>
       <p:nvGrpSpPr>
-        <p:cNvPr id="80" name="Shape 80"/>
+        <p:cNvPr id="81" name="Shape 81"/>
         <p:cNvGrpSpPr/>
         <p:nvPr/>
       </p:nvGrpSpPr>
@@ -1305,7 +1305,7 @@
       </p:grpSpPr>
       <p:sp>
         <p:nvSpPr>
-          <p:cNvPr id="81" name="Google Shape;81;g3f5e06a3c09_0_16:notes"/>
+          <p:cNvPr id="82" name="Google Shape;82;g3f5e06a3c09_0_16:notes"/>
           <p:cNvSpPr/>
           <p:nvPr>
             <p:ph idx="2" type="sldImg"/>
@@ -1340,7 +1340,7 @@
       </p:sp>
       <p:sp>
         <p:nvSpPr>
-          <p:cNvPr id="82" name="Google Shape;82;g3f5e06a3c09_0_16:notes"/>
+          <p:cNvPr id="83" name="Google Shape;83;g3f5e06a3c09_0_16:notes"/>
           <p:cNvSpPr txBox="1"/>
           <p:nvPr>
             <p:ph idx="1" type="body"/>
@@ -6291,6 +6291,34 @@
           </a:ln>
         </p:spPr>
       </p:pic>
+      <p:pic>
+        <p:nvPicPr>
+          <p:cNvPr id="75" name="Google Shape;75;p17"/>
+          <p:cNvPicPr preferRelativeResize="0"/>
+          <p:nvPr/>
+        </p:nvPicPr>
+        <p:blipFill>
+          <a:blip r:embed="rId4">
+            <a:alphaModFix/>
+          </a:blip>
+          <a:stretch>
+            <a:fillRect/>
+          </a:stretch>
+        </p:blipFill>
+        <p:spPr>
+          <a:xfrm>
+            <a:off x="7884220" y="1360626"/>
+            <a:ext cx="2490127" cy="1659676"/>
+          </a:xfrm>
+          <a:prstGeom prst="rect">
+            <a:avLst/>
+          </a:prstGeom>
+          <a:noFill/>
+          <a:ln>
+            <a:noFill/>
+          </a:ln>
+        </p:spPr>
+      </p:pic>
     </p:spTree>
   </p:cSld>
   <p:clrMapOvr>
@@ -6304,7 +6332,7 @@
   <p:cSld>
     <p:spTree>
       <p:nvGrpSpPr>
-        <p:cNvPr id="78" name="Shape 78"/>
+        <p:cNvPr id="79" name="Shape 79"/>
         <p:cNvGrpSpPr/>
         <p:nvPr/>
       </p:nvGrpSpPr>
@@ -6318,7 +6346,7 @@
       </p:grpSpPr>
       <p:pic>
         <p:nvPicPr>
-          <p:cNvPr id="79" name="Google Shape;79;p18" title="summary_noise.jpg"/>
+          <p:cNvPr id="80" name="Google Shape;80;p18" title="summary_noise.jpg"/>
           <p:cNvPicPr preferRelativeResize="0"/>
           <p:nvPr/>
         </p:nvPicPr>
@@ -6357,7 +6385,7 @@
   <p:cSld>
     <p:spTree>
       <p:nvGrpSpPr>
-        <p:cNvPr id="83" name="Shape 83"/>
+        <p:cNvPr id="84" name="Shape 84"/>
         <p:cNvGrpSpPr/>
         <p:nvPr/>
       </p:nvGrpSpPr>
@@ -6371,7 +6399,7 @@
       </p:grpSpPr>
       <p:pic>
         <p:nvPicPr>
-          <p:cNvPr id="84" name="Google Shape;84;p19" title="remap_tf_noise_gsea.jpg"/>
+          <p:cNvPr id="85" name="Google Shape;85;p19" title="remap_tf_noise_gsea.jpg"/>
           <p:cNvPicPr preferRelativeResize="0"/>
           <p:nvPr/>
         </p:nvPicPr>
@@ -6406,6 +6434,285 @@
 </file>
 
 <file path=ppt/theme/theme1.xml><?xml version="1.0" encoding="utf-8"?>
+<a:theme xmlns:a="http://schemas.openxmlformats.org/drawingml/2006/main" xmlns:r="http://schemas.openxmlformats.org/officeDocument/2006/relationships" name="Simple Light">
+  <a:themeElements>
+    <a:clrScheme name="Simple Light">
+      <a:dk1>
+        <a:srgbClr val="000000"/>
+      </a:dk1>
+      <a:lt1>
+        <a:srgbClr val="FFFFFF"/>
+      </a:lt1>
+      <a:dk2>
+        <a:srgbClr val="595959"/>
+      </a:dk2>
+      <a:lt2>
+        <a:srgbClr val="EEEEEE"/>
+      </a:lt2>
+      <a:accent1>
+        <a:srgbClr val="4285F4"/>
+      </a:accent1>
+      <a:accent2>
+        <a:srgbClr val="212121"/>
+      </a:accent2>
+      <a:accent3>
+        <a:srgbClr val="78909C"/>
+      </a:accent3>
+      <a:accent4>
+        <a:srgbClr val="FFAB40"/>
+      </a:accent4>
+      <a:accent5>
+        <a:srgbClr val="0097A7"/>
+      </a:accent5>
+      <a:accent6>
+        <a:srgbClr val="EEFF41"/>
+      </a:accent6>
+      <a:hlink>
+        <a:srgbClr val="0097A7"/>
+      </a:hlink>
+      <a:folHlink>
+        <a:srgbClr val="0097A7"/>
+      </a:folHlink>
+    </a:clrScheme>
+    <a:fontScheme name="Office">
+      <a:majorFont>
+        <a:latin typeface="Arial"/>
+        <a:ea typeface=""/>
+        <a:cs typeface=""/>
+        <a:font script="Jpan" typeface="ＭＳ Ｐゴシック"/>
+        <a:font script="Hang" typeface="맑은 고딕"/>
+        <a:font script="Hans" typeface="宋体"/>
+        <a:font script="Hant" typeface="新細明體"/>
+        <a:font script="Arab" typeface="Times New Roman"/>
+        <a:font script="Hebr" typeface="Times New Roman"/>
+        <a:font script="Thai" typeface="Angsana New"/>
+        <a:font script="Ethi" typeface="Nyala"/>
+        <a:font script="Beng" typeface="Vrinda"/>
+        <a:font script="Gujr" typeface="Shruti"/>
+        <a:font script="Khmr" typeface="MoolBoran"/>
+        <a:font script="Knda" typeface="Tunga"/>
+        <a:font script="Guru" typeface="Raavi"/>
+        <a:font script="Cans" typeface="Euphemia"/>
+        <a:font script="Cher" typeface="Plantagenet Cherokee"/>
+        <a:font script="Yiii" typeface="Microsoft Yi Baiti"/>
+        <a:font script="Tibt" typeface="Microsoft Himalaya"/>
+        <a:font script="Thaa" typeface="MV Boli"/>
+        <a:font script="Deva" typeface="Mangal"/>
+        <a:font script="Telu" typeface="Gautami"/>
+        <a:font script="Taml" typeface="Latha"/>
+        <a:font script="Syrc" typeface="Estrangelo Edessa"/>
+        <a:font script="Orya" typeface="Kalinga"/>
+        <a:font script="Mlym" typeface="Kartika"/>
+        <a:font script="Laoo" typeface="DokChampa"/>
+        <a:font script="Sinh" typeface="Iskoola Pota"/>
+        <a:font script="Mong" typeface="Mongolian Baiti"/>
+        <a:font script="Viet" typeface="Times New Roman"/>
+        <a:font script="Uigh" typeface="Microsoft Uighur"/>
+        <a:font script="Geor" typeface="Sylfaen"/>
+      </a:majorFont>
+      <a:minorFont>
+        <a:latin typeface="Arial"/>
+        <a:ea typeface=""/>
+        <a:cs typeface=""/>
+        <a:font script="Jpan" typeface="ＭＳ Ｐゴシック"/>
+        <a:font script="Hang" typeface="맑은 고딕"/>
+        <a:font script="Hans" typeface="宋体"/>
+        <a:font script="Hant" typeface="新細明體"/>
+        <a:font script="Arab" typeface="Arial"/>
+        <a:font script="Hebr" typeface="Arial"/>
+        <a:font script="Thai" typeface="Cordia New"/>
+        <a:font script="Ethi" typeface="Nyala"/>
+        <a:font script="Beng" typeface="Vrinda"/>
+        <a:font script="Gujr" typeface="Shruti"/>
+        <a:font script="Khmr" typeface="DaunPenh"/>
+        <a:font script="Knda" typeface="Tunga"/>
+        <a:font script="Guru" typeface="Raavi"/>
+        <a:font script="Cans" typeface="Euphemia"/>
+        <a:font script="Cher" typeface="Plantagenet Cherokee"/>
+        <a:font script="Yiii" typeface="Microsoft Yi Baiti"/>
+        <a:font script="Tibt" typeface="Microsoft Himalaya"/>
+        <a:font script="Thaa" typeface="MV Boli"/>
+        <a:font script="Deva" typeface="Mangal"/>
+        <a:font script="Telu" typeface="Gautami"/>
+        <a:font script="Taml" typeface="Latha"/>
+        <a:font script="Syrc" typeface="Estrangelo Edessa"/>
+        <a:font script="Orya" typeface="Kalinga"/>
+        <a:font script="Mlym" typeface="Kartika"/>
+        <a:font script="Laoo" typeface="DokChampa"/>
+        <a:font script="Sinh" typeface="Iskoola Pota"/>
+        <a:font script="Mong" typeface="Mongolian Baiti"/>
+        <a:font script="Viet" typeface="Arial"/>
+        <a:font script="Uigh" typeface="Microsoft Uighur"/>
+        <a:font script="Geor" typeface="Sylfaen"/>
+      </a:minorFont>
+    </a:fontScheme>
+    <a:fmtScheme name="Office">
+      <a:fillStyleLst>
+        <a:solidFill>
+          <a:schemeClr val="phClr"/>
+        </a:solidFill>
+        <a:gradFill rotWithShape="1">
+          <a:gsLst>
+            <a:gs pos="0">
+              <a:schemeClr val="phClr">
+                <a:tint val="50000"/>
+                <a:satMod val="300000"/>
+              </a:schemeClr>
+            </a:gs>
+            <a:gs pos="35000">
+              <a:schemeClr val="phClr">
+                <a:tint val="37000"/>
+                <a:satMod val="300000"/>
+              </a:schemeClr>
+            </a:gs>
+            <a:gs pos="100000">
+              <a:schemeClr val="phClr">
+                <a:tint val="15000"/>
+                <a:satMod val="350000"/>
+              </a:schemeClr>
+            </a:gs>
+          </a:gsLst>
+          <a:lin ang="16200000" scaled="1"/>
+        </a:gradFill>
+        <a:gradFill rotWithShape="1">
+          <a:gsLst>
+            <a:gs pos="0">
+              <a:schemeClr val="phClr">
+                <a:tint val="100000"/>
+                <a:shade val="100000"/>
+                <a:satMod val="130000"/>
+              </a:schemeClr>
+            </a:gs>
+            <a:gs pos="100000">
+              <a:schemeClr val="phClr">
+                <a:tint val="50000"/>
+                <a:shade val="100000"/>
+                <a:satMod val="350000"/>
+              </a:schemeClr>
+            </a:gs>
+          </a:gsLst>
+          <a:lin ang="16200000" scaled="0"/>
+        </a:gradFill>
+      </a:fillStyleLst>
+      <a:lnStyleLst>
+        <a:ln w="9525" cap="flat" cmpd="sng" algn="ctr">
+          <a:solidFill>
+            <a:schemeClr val="phClr">
+              <a:shade val="95000"/>
+              <a:satMod val="105000"/>
+            </a:schemeClr>
+          </a:solidFill>
+          <a:prstDash val="solid"/>
+        </a:ln>
+        <a:ln w="25400" cap="flat" cmpd="sng" algn="ctr">
+          <a:solidFill>
+            <a:schemeClr val="phClr"/>
+          </a:solidFill>
+          <a:prstDash val="solid"/>
+        </a:ln>
+        <a:ln w="38100" cap="flat" cmpd="sng" algn="ctr">
+          <a:solidFill>
+            <a:schemeClr val="phClr"/>
+          </a:solidFill>
+          <a:prstDash val="solid"/>
+        </a:ln>
+      </a:lnStyleLst>
+      <a:effectStyleLst>
+        <a:effectStyle>
+          <a:effectLst>
+            <a:outerShdw blurRad="40000" dist="20000" dir="5400000" rotWithShape="0">
+              <a:srgbClr val="000000">
+                <a:alpha val="38000"/>
+              </a:srgbClr>
+            </a:outerShdw>
+          </a:effectLst>
+        </a:effectStyle>
+        <a:effectStyle>
+          <a:effectLst>
+            <a:outerShdw blurRad="40000" dist="23000" dir="5400000" rotWithShape="0">
+              <a:srgbClr val="000000">
+                <a:alpha val="35000"/>
+              </a:srgbClr>
+            </a:outerShdw>
+          </a:effectLst>
+        </a:effectStyle>
+        <a:effectStyle>
+          <a:effectLst>
+            <a:outerShdw blurRad="40000" dist="23000" dir="5400000" rotWithShape="0">
+              <a:srgbClr val="000000">
+                <a:alpha val="35000"/>
+              </a:srgbClr>
+            </a:outerShdw>
+          </a:effectLst>
+          <a:scene3d>
+            <a:camera prst="orthographicFront">
+              <a:rot lat="0" lon="0" rev="0"/>
+            </a:camera>
+            <a:lightRig rig="threePt" dir="t">
+              <a:rot lat="0" lon="0" rev="1200000"/>
+            </a:lightRig>
+          </a:scene3d>
+          <a:sp3d>
+            <a:bevelT w="63500" h="25400"/>
+          </a:sp3d>
+        </a:effectStyle>
+      </a:effectStyleLst>
+      <a:bgFillStyleLst>
+        <a:solidFill>
+          <a:schemeClr val="phClr"/>
+        </a:solidFill>
+        <a:gradFill rotWithShape="1">
+          <a:gsLst>
+            <a:gs pos="0">
+              <a:schemeClr val="phClr">
+                <a:tint val="40000"/>
+                <a:satMod val="350000"/>
+              </a:schemeClr>
+            </a:gs>
+            <a:gs pos="40000">
+              <a:schemeClr val="phClr">
+                <a:tint val="45000"/>
+                <a:shade val="99000"/>
+                <a:satMod val="350000"/>
+              </a:schemeClr>
+            </a:gs>
+            <a:gs pos="100000">
+              <a:schemeClr val="phClr">
+                <a:shade val="20000"/>
+                <a:satMod val="255000"/>
+              </a:schemeClr>
+            </a:gs>
+          </a:gsLst>
+          <a:path path="circle">
+            <a:fillToRect l="50000" t="-80000" r="50000" b="180000"/>
+          </a:path>
+        </a:gradFill>
+        <a:gradFill rotWithShape="1">
+          <a:gsLst>
+            <a:gs pos="0">
+              <a:schemeClr val="phClr">
+                <a:tint val="80000"/>
+                <a:satMod val="300000"/>
+              </a:schemeClr>
+            </a:gs>
+            <a:gs pos="100000">
+              <a:schemeClr val="phClr">
+                <a:shade val="30000"/>
+                <a:satMod val="200000"/>
+              </a:schemeClr>
+            </a:gs>
+          </a:gsLst>
+          <a:path path="circle">
+            <a:fillToRect l="50000" t="50000" r="50000" b="50000"/>
+          </a:path>
+        </a:gradFill>
+      </a:bgFillStyleLst>
+    </a:fmtScheme>
+  </a:themeElements>
+</a:theme>
+</file>
+
+<file path=ppt/theme/theme2.xml><?xml version="1.0" encoding="utf-8"?>
 <a:theme xmlns:a="http://schemas.openxmlformats.org/drawingml/2006/main" xmlns:r="http://schemas.openxmlformats.org/officeDocument/2006/relationships">
   <a:themeElements>
     <a:clrScheme name="Default">
@@ -6682,283 +6989,4 @@
     </a:fmtScheme>
   </a:themeElements>
 </a:theme>
-</file>
-
-<file path=ppt/theme/theme2.xml><?xml version="1.0" encoding="utf-8"?>
-<a:theme xmlns:a="http://schemas.openxmlformats.org/drawingml/2006/main" xmlns:r="http://schemas.openxmlformats.org/officeDocument/2006/relationships" name="Simple Light">
-  <a:themeElements>
-    <a:clrScheme name="Simple Light">
-      <a:dk1>
-        <a:srgbClr val="000000"/>
-      </a:dk1>
-      <a:lt1>
-        <a:srgbClr val="FFFFFF"/>
-      </a:lt1>
-      <a:dk2>
-        <a:srgbClr val="595959"/>
-      </a:dk2>
-      <a:lt2>
-        <a:srgbClr val="EEEEEE"/>
-      </a:lt2>
-      <a:accent1>
-        <a:srgbClr val="4285F4"/>
-      </a:accent1>
-      <a:accent2>
-        <a:srgbClr val="212121"/>
-      </a:accent2>
-      <a:accent3>
-        <a:srgbClr val="78909C"/>
-      </a:accent3>
-      <a:accent4>
-        <a:srgbClr val="FFAB40"/>
-      </a:accent4>
-      <a:accent5>
-        <a:srgbClr val="0097A7"/>
-      </a:accent5>
-      <a:accent6>
-        <a:srgbClr val="EEFF41"/>
-      </a:accent6>
-      <a:hlink>
-        <a:srgbClr val="0097A7"/>
-      </a:hlink>
-      <a:folHlink>
-        <a:srgbClr val="0097A7"/>
-      </a:folHlink>
-    </a:clrScheme>
-    <a:fontScheme name="Office">
-      <a:majorFont>
-        <a:latin typeface="Arial"/>
-        <a:ea typeface=""/>
-        <a:cs typeface=""/>
-        <a:font script="Jpan" typeface="ＭＳ Ｐゴシック"/>
-        <a:font script="Hang" typeface="맑은 고딕"/>
-        <a:font script="Hans" typeface="宋体"/>
-        <a:font script="Hant" typeface="新細明體"/>
-        <a:font script="Arab" typeface="Times New Roman"/>
-        <a:font script="Hebr" typeface="Times New Roman"/>
-        <a:font script="Thai" typeface="Angsana New"/>
-        <a:font script="Ethi" typeface="Nyala"/>
-        <a:font script="Beng" typeface="Vrinda"/>
-        <a:font script="Gujr" typeface="Shruti"/>
-        <a:font script="Khmr" typeface="MoolBoran"/>
-        <a:font script="Knda" typeface="Tunga"/>
-        <a:font script="Guru" typeface="Raavi"/>
-        <a:font script="Cans" typeface="Euphemia"/>
-        <a:font script="Cher" typeface="Plantagenet Cherokee"/>
-        <a:font script="Yiii" typeface="Microsoft Yi Baiti"/>
-        <a:font script="Tibt" typeface="Microsoft Himalaya"/>
-        <a:font script="Thaa" typeface="MV Boli"/>
-        <a:font script="Deva" typeface="Mangal"/>
-        <a:font script="Telu" typeface="Gautami"/>
-        <a:font script="Taml" typeface="Latha"/>
-        <a:font script="Syrc" typeface="Estrangelo Edessa"/>
-        <a:font script="Orya" typeface="Kalinga"/>
-        <a:font script="Mlym" typeface="Kartika"/>
-        <a:font script="Laoo" typeface="DokChampa"/>
-        <a:font script="Sinh" typeface="Iskoola Pota"/>
-        <a:font script="Mong" typeface="Mongolian Baiti"/>
-        <a:font script="Viet" typeface="Times New Roman"/>
-        <a:font script="Uigh" typeface="Microsoft Uighur"/>
-        <a:font script="Geor" typeface="Sylfaen"/>
-      </a:majorFont>
-      <a:minorFont>
-        <a:latin typeface="Arial"/>
-        <a:ea typeface=""/>
-        <a:cs typeface=""/>
-        <a:font script="Jpan" typeface="ＭＳ Ｐゴシック"/>
-        <a:font script="Hang" typeface="맑은 고딕"/>
-        <a:font script="Hans" typeface="宋体"/>
-        <a:font script="Hant" typeface="新細明體"/>
-        <a:font script="Arab" typeface="Arial"/>
-        <a:font script="Hebr" typeface="Arial"/>
-        <a:font script="Thai" typeface="Cordia New"/>
-        <a:font script="Ethi" typeface="Nyala"/>
-        <a:font script="Beng" typeface="Vrinda"/>
-        <a:font script="Gujr" typeface="Shruti"/>
-        <a:font script="Khmr" typeface="DaunPenh"/>
-        <a:font script="Knda" typeface="Tunga"/>
-        <a:font script="Guru" typeface="Raavi"/>
-        <a:font script="Cans" typeface="Euphemia"/>
-        <a:font script="Cher" typeface="Plantagenet Cherokee"/>
-        <a:font script="Yiii" typeface="Microsoft Yi Baiti"/>
-        <a:font script="Tibt" typeface="Microsoft Himalaya"/>
-        <a:font script="Thaa" typeface="MV Boli"/>
-        <a:font script="Deva" typeface="Mangal"/>
-        <a:font script="Telu" typeface="Gautami"/>
-        <a:font script="Taml" typeface="Latha"/>
-        <a:font script="Syrc" typeface="Estrangelo Edessa"/>
-        <a:font script="Orya" typeface="Kalinga"/>
-        <a:font script="Mlym" typeface="Kartika"/>
-        <a:font script="Laoo" typeface="DokChampa"/>
-        <a:font script="Sinh" typeface="Iskoola Pota"/>
-        <a:font script="Mong" typeface="Mongolian Baiti"/>
-        <a:font script="Viet" typeface="Arial"/>
-        <a:font script="Uigh" typeface="Microsoft Uighur"/>
-        <a:font script="Geor" typeface="Sylfaen"/>
-      </a:minorFont>
-    </a:fontScheme>
-    <a:fmtScheme name="Office">
-      <a:fillStyleLst>
-        <a:solidFill>
-          <a:schemeClr val="phClr"/>
-        </a:solidFill>
-        <a:gradFill rotWithShape="1">
-          <a:gsLst>
-            <a:gs pos="0">
-              <a:schemeClr val="phClr">
-                <a:tint val="50000"/>
-                <a:satMod val="300000"/>
-              </a:schemeClr>
-            </a:gs>
-            <a:gs pos="35000">
-              <a:schemeClr val="phClr">
-                <a:tint val="37000"/>
-                <a:satMod val="300000"/>
-              </a:schemeClr>
-            </a:gs>
-            <a:gs pos="100000">
-              <a:schemeClr val="phClr">
-                <a:tint val="15000"/>
-                <a:satMod val="350000"/>
-              </a:schemeClr>
-            </a:gs>
-          </a:gsLst>
-          <a:lin ang="16200000" scaled="1"/>
-        </a:gradFill>
-        <a:gradFill rotWithShape="1">
-          <a:gsLst>
-            <a:gs pos="0">
-              <a:schemeClr val="phClr">
-                <a:tint val="100000"/>
-                <a:shade val="100000"/>
-                <a:satMod val="130000"/>
-              </a:schemeClr>
-            </a:gs>
-            <a:gs pos="100000">
-              <a:schemeClr val="phClr">
-                <a:tint val="50000"/>
-                <a:shade val="100000"/>
-                <a:satMod val="350000"/>
-              </a:schemeClr>
-            </a:gs>
-          </a:gsLst>
-          <a:lin ang="16200000" scaled="0"/>
-        </a:gradFill>
-      </a:fillStyleLst>
-      <a:lnStyleLst>
-        <a:ln w="9525" cap="flat" cmpd="sng" algn="ctr">
-          <a:solidFill>
-            <a:schemeClr val="phClr">
-              <a:shade val="95000"/>
-              <a:satMod val="105000"/>
-            </a:schemeClr>
-          </a:solidFill>
-          <a:prstDash val="solid"/>
-        </a:ln>
-        <a:ln w="25400" cap="flat" cmpd="sng" algn="ctr">
-          <a:solidFill>
-            <a:schemeClr val="phClr"/>
-          </a:solidFill>
-          <a:prstDash val="solid"/>
-        </a:ln>
-        <a:ln w="38100" cap="flat" cmpd="sng" algn="ctr">
-          <a:solidFill>
-            <a:schemeClr val="phClr"/>
-          </a:solidFill>
-          <a:prstDash val="solid"/>
-        </a:ln>
-      </a:lnStyleLst>
-      <a:effectStyleLst>
-        <a:effectStyle>
-          <a:effectLst>
-            <a:outerShdw blurRad="40000" dist="20000" dir="5400000" rotWithShape="0">
-              <a:srgbClr val="000000">
-                <a:alpha val="38000"/>
-              </a:srgbClr>
-            </a:outerShdw>
-          </a:effectLst>
-        </a:effectStyle>
-        <a:effectStyle>
-          <a:effectLst>
-            <a:outerShdw blurRad="40000" dist="23000" dir="5400000" rotWithShape="0">
-              <a:srgbClr val="000000">
-                <a:alpha val="35000"/>
-              </a:srgbClr>
-            </a:outerShdw>
-          </a:effectLst>
-        </a:effectStyle>
-        <a:effectStyle>
-          <a:effectLst>
-            <a:outerShdw blurRad="40000" dist="23000" dir="5400000" rotWithShape="0">
-              <a:srgbClr val="000000">
-                <a:alpha val="35000"/>
-              </a:srgbClr>
-            </a:outerShdw>
-          </a:effectLst>
-          <a:scene3d>
-            <a:camera prst="orthographicFront">
-              <a:rot lat="0" lon="0" rev="0"/>
-            </a:camera>
-            <a:lightRig rig="threePt" dir="t">
-              <a:rot lat="0" lon="0" rev="1200000"/>
-            </a:lightRig>
-          </a:scene3d>
-          <a:sp3d>
-            <a:bevelT w="63500" h="25400"/>
-          </a:sp3d>
-        </a:effectStyle>
-      </a:effectStyleLst>
-      <a:bgFillStyleLst>
-        <a:solidFill>
-          <a:schemeClr val="phClr"/>
-        </a:solidFill>
-        <a:gradFill rotWithShape="1">
-          <a:gsLst>
-            <a:gs pos="0">
-              <a:schemeClr val="phClr">
-                <a:tint val="40000"/>
-                <a:satMod val="350000"/>
-              </a:schemeClr>
-            </a:gs>
-            <a:gs pos="40000">
-              <a:schemeClr val="phClr">
-                <a:tint val="45000"/>
-                <a:shade val="99000"/>
-                <a:satMod val="350000"/>
-              </a:schemeClr>
-            </a:gs>
-            <a:gs pos="100000">
-              <a:schemeClr val="phClr">
-                <a:shade val="20000"/>
-                <a:satMod val="255000"/>
-              </a:schemeClr>
-            </a:gs>
-          </a:gsLst>
-          <a:path path="circle">
-            <a:fillToRect l="50000" t="-80000" r="50000" b="180000"/>
-          </a:path>
-        </a:gradFill>
-        <a:gradFill rotWithShape="1">
-          <a:gsLst>
-            <a:gs pos="0">
-              <a:schemeClr val="phClr">
-                <a:tint val="80000"/>
-                <a:satMod val="300000"/>
-              </a:schemeClr>
-            </a:gs>
-            <a:gs pos="100000">
-              <a:schemeClr val="phClr">
-                <a:shade val="30000"/>
-                <a:satMod val="200000"/>
-              </a:schemeClr>
-            </a:gs>
-          </a:gsLst>
-          <a:path path="circle">
-            <a:fillToRect l="50000" t="50000" r="50000" b="50000"/>
-          </a:path>
-        </a:gradFill>
-      </a:bgFillStyleLst>
-    </a:fmtScheme>
-  </a:themeElements>
-</a:theme>
 </file>
</xml_diff>